<commit_message>
List the five team members on the title slide and in the licence
</commit_message>
<xml_diff>
--- a/docs/slides.pptx
+++ b/docs/slides.pptx
@@ -2331,7 +2331,7 @@
               <a:buNone/>
             </a:pPr>
             <a:r>
-              <a:rPr lang="en-US" sz="2000" b="1" dirty="0">
+              <a:rPr lang="en-US" sz="1800" b="1" dirty="0">
                 <a:solidFill>
                   <a:schemeClr val="tx1"/>
                 </a:solidFill>
@@ -2339,7 +2339,7 @@
                 <a:ea typeface="Calibri" pitchFamily="34" charset="-122"/>
                 <a:cs typeface="Calibri" pitchFamily="34" charset="-120"/>
               </a:rPr>
-              <a:t>Sanae Belfrouh · Wiame Kane</a:t>
+              <a:t>Sanae Belfrouh · Wiame Kane · Yassine Azmou · Mohammed Yassine Sof · Hajar Elouatiq</a:t>
             </a:r>
             <a:endParaRPr lang="en-US" sz="1800" dirty="0"/>
           </a:p>

</xml_diff>

<commit_message>
Slides: forest and space design
Backgrounds generated from the project data: relief of the study area
from the DEM, NASA FIRMS fires and an observation satellite on the
title and closing slides; contour lines and an orbiting satellite on
the content slides; flame icons on the key figures. Every image has
alternative text.
</commit_message>
<xml_diff>
--- a/docs/slides.pptx
+++ b/docs/slides.pptx
@@ -1647,9 +1647,16 @@
   <p:cSld name="TITLE">
     <p:bg>
       <p:bgPr>
-        <a:solidFill>
-          <a:schemeClr val="bg1"/>
-        </a:solidFill>
+        <a:blipFill dpi="0" rotWithShape="1">
+          <a:blip r:embed="rId1">
+            <a:lum/>
+          </a:blip>
+          <a:srcRect/>
+          <a:stretch>
+            <a:fillRect/>
+          </a:stretch>
+        </a:blipFill>
+        <a:effectLst/>
       </p:bgPr>
     </p:bg>
     <p:spTree>
@@ -1676,8 +1683,8 @@
         </p:nvSpPr>
         <p:spPr>
           <a:xfrm>
-            <a:off x="914400" y="1417320"/>
-            <a:ext cx="10362895" cy="1737360"/>
+            <a:off x="548640" y="914400"/>
+            <a:ext cx="5394960" cy="2651760"/>
           </a:xfrm>
           <a:prstGeom prst="rect">
             <a:avLst/>
@@ -1688,11 +1695,11 @@
         <p:txBody>
           <a:bodyPr wrap="square" rtlCol="0"/>
           <a:lstStyle>
-            <a:lvl1pPr algn="ctr" indent="0" marL="0">
+            <a:lvl1pPr algn="l" indent="0" marL="0">
               <a:buNone/>
               <a:defRPr lang="en-US" sz="3600" b="1" dirty="0">
                 <a:solidFill>
-                  <a:schemeClr val="accent1"/>
+                  <a:schemeClr val="bg1"/>
                 </a:solidFill>
                 <a:latin typeface="Cambria" pitchFamily="34" charset="0"/>
                 <a:ea typeface="Cambria" pitchFamily="34" charset="-122"/>
@@ -1701,7 +1708,7 @@
             </a:lvl1pPr>
           </a:lstStyle>
           <a:p>
-            <a:pPr algn="ctr" indent="0" marL="0">
+            <a:pPr algn="l" indent="0" marL="0">
               <a:buNone/>
             </a:pPr>
             <a:endParaRPr lang="en-US" sz="3600" dirty="0"/>
@@ -1718,8 +1725,8 @@
         </p:nvSpPr>
         <p:spPr>
           <a:xfrm>
-            <a:off x="914400" y="3429000"/>
-            <a:ext cx="10362895" cy="2651760"/>
+            <a:off x="548640" y="3794760"/>
+            <a:ext cx="5120640" cy="2651760"/>
           </a:xfrm>
           <a:prstGeom prst="rect">
             <a:avLst/>
@@ -1730,11 +1737,11 @@
         <p:txBody>
           <a:bodyPr wrap="square" rtlCol="0"/>
           <a:lstStyle>
-            <a:lvl1pPr algn="ctr" indent="0" marL="0">
+            <a:lvl1pPr algn="l" indent="0" marL="0">
               <a:buNone/>
-              <a:defRPr lang="en-US" sz="1800" dirty="0">
-                <a:solidFill>
-                  <a:schemeClr val="tx1"/>
+              <a:defRPr lang="en-US" sz="1600" dirty="0">
+                <a:solidFill>
+                  <a:srgbClr val="D8E8DC"/>
                 </a:solidFill>
                 <a:latin typeface="Calibri" pitchFamily="34" charset="0"/>
                 <a:ea typeface="Calibri" pitchFamily="34" charset="-122"/>
@@ -1743,10 +1750,10 @@
             </a:lvl1pPr>
           </a:lstStyle>
           <a:p>
-            <a:pPr algn="ctr" indent="0" marL="0">
+            <a:pPr algn="l" indent="0" marL="0">
               <a:buNone/>
             </a:pPr>
-            <a:endParaRPr lang="en-US" sz="1800" dirty="0"/>
+            <a:endParaRPr lang="en-US" sz="1600" dirty="0"/>
           </a:p>
         </p:txBody>
       </p:sp>
@@ -1763,9 +1770,16 @@
   <p:cSld name="CONTENT">
     <p:bg>
       <p:bgPr>
-        <a:solidFill>
-          <a:schemeClr val="bg1"/>
-        </a:solidFill>
+        <a:blipFill dpi="0" rotWithShape="1">
+          <a:blip r:embed="rId1">
+            <a:lum/>
+          </a:blip>
+          <a:srcRect/>
+          <a:stretch>
+            <a:fillRect/>
+          </a:stretch>
+        </a:blipFill>
+        <a:effectLst/>
       </p:bgPr>
     </p:bg>
     <p:spTree>
@@ -1793,7 +1807,7 @@
         <p:spPr>
           <a:xfrm>
             <a:off x="548640" y="320040"/>
-            <a:ext cx="11094415" cy="868680"/>
+            <a:ext cx="10180015" cy="868680"/>
           </a:xfrm>
           <a:prstGeom prst="rect">
             <a:avLst/>
@@ -1906,6 +1920,174 @@
             <a:fld id="{F7021451-1387-4CA6-816F-3879F97B5CBC}" type="slidenum">
               <a:rPr b="0" lang="en-US"/>
               <a:t>1003</a:t>
+            </a:fld>
+            <a:endParaRPr lang="en-US"/>
+          </a:p>
+        </p:txBody>
+      </p:sp>
+    </p:spTree>
+  </p:cSld>
+  <p:clrMapOvr>
+    <a:masterClrMapping/>
+  </p:clrMapOvr>
+</p:sldLayout>
+</file>
+
+<file path=ppt/slideLayouts/slideLayout4.xml><?xml version="1.0" encoding="utf-8"?>
+<p:sldLayout xmlns:a="http://schemas.openxmlformats.org/drawingml/2006/main" xmlns:r="http://schemas.openxmlformats.org/officeDocument/2006/relationships" xmlns:p="http://schemas.openxmlformats.org/presentationml/2006/main" preserve="1">
+  <p:cSld name="CLOSING">
+    <p:bg>
+      <p:bgPr>
+        <a:blipFill dpi="0" rotWithShape="1">
+          <a:blip r:embed="rId1">
+            <a:lum/>
+          </a:blip>
+          <a:srcRect/>
+          <a:stretch>
+            <a:fillRect/>
+          </a:stretch>
+        </a:blipFill>
+        <a:effectLst/>
+      </p:bgPr>
+    </p:bg>
+    <p:spTree>
+      <p:nvGrpSpPr>
+        <p:cNvPr id="1" name=""/>
+        <p:cNvGrpSpPr/>
+        <p:nvPr/>
+      </p:nvGrpSpPr>
+      <p:grpSpPr>
+        <a:xfrm>
+          <a:off x="0" y="0"/>
+          <a:ext cx="0" cy="0"/>
+          <a:chOff x="0" y="0"/>
+          <a:chExt cx="0" cy="0"/>
+        </a:xfrm>
+      </p:grpSpPr>
+      <p:sp>
+        <p:nvSpPr>
+          <p:cNvPr id="2" name="Text 0"/>
+          <p:cNvSpPr/>
+          <p:nvPr>
+            <p:ph idx="100" type="title" hasCustomPrompt="1"/>
+          </p:nvPr>
+        </p:nvSpPr>
+        <p:spPr>
+          <a:xfrm>
+            <a:off x="548640" y="320040"/>
+            <a:ext cx="5669280" cy="868680"/>
+          </a:xfrm>
+          <a:prstGeom prst="rect">
+            <a:avLst/>
+          </a:prstGeom>
+          <a:noFill/>
+          <a:ln/>
+        </p:spPr>
+        <p:txBody>
+          <a:bodyPr wrap="square" rtlCol="0"/>
+          <a:lstStyle>
+            <a:lvl1pPr algn="l" indent="0" marL="0">
+              <a:buNone/>
+              <a:defRPr lang="en-US" sz="2800" b="1" dirty="0">
+                <a:solidFill>
+                  <a:schemeClr val="bg1"/>
+                </a:solidFill>
+                <a:latin typeface="Cambria" pitchFamily="34" charset="0"/>
+                <a:ea typeface="Cambria" pitchFamily="34" charset="-122"/>
+                <a:cs typeface="Cambria" pitchFamily="34" charset="-120"/>
+              </a:defRPr>
+            </a:lvl1pPr>
+          </a:lstStyle>
+          <a:p>
+            <a:pPr algn="l" indent="0" marL="0">
+              <a:buNone/>
+            </a:pPr>
+            <a:endParaRPr lang="en-US" sz="2800" dirty="0"/>
+          </a:p>
+        </p:txBody>
+      </p:sp>
+      <p:sp>
+        <p:nvSpPr>
+          <p:cNvPr id="3" name="Text 0"/>
+          <p:cNvSpPr/>
+          <p:nvPr/>
+        </p:nvSpPr>
+        <p:spPr>
+          <a:xfrm>
+            <a:off x="548640" y="6419088"/>
+            <a:ext cx="8229600" cy="274320"/>
+          </a:xfrm>
+          <a:prstGeom prst="rect">
+            <a:avLst/>
+          </a:prstGeom>
+          <a:noFill/>
+          <a:ln/>
+        </p:spPr>
+        <p:txBody>
+          <a:bodyPr wrap="square" lIns="0" tIns="0" rIns="0" bIns="0" rtlCol="0" anchor="ctr"/>
+          <a:lstStyle/>
+          <a:p>
+            <a:pPr indent="0" marL="0">
+              <a:buNone/>
+            </a:pPr>
+            <a:r>
+              <a:rPr lang="en-US" sz="1000" dirty="0">
+                <a:solidFill>
+                  <a:srgbClr val="9DB8A8"/>
+                </a:solidFill>
+                <a:latin typeface="Calibri" pitchFamily="34" charset="0"/>
+                <a:ea typeface="Calibri" pitchFamily="34" charset="-122"/>
+                <a:cs typeface="Calibri" pitchFamily="34" charset="-120"/>
+              </a:rPr>
+              <a:t>Wiqaya · Arab Youth Space Hackathon 2026 · Climate &amp; Disaster Resilience</a:t>
+            </a:r>
+            <a:endParaRPr lang="en-US" sz="1000" dirty="0"/>
+          </a:p>
+        </p:txBody>
+      </p:sp>
+      <p:sp>
+        <p:nvSpPr>
+          <p:cNvPr id="25" name="Slide Number Placeholder 0"/>
+          <p:cNvSpPr>
+            <a:spLocks noGrp="1"/>
+          </p:cNvSpPr>
+          <p:nvPr>
+            <p:ph type="sldNum" sz="quarter" idx="4294967295"/>
+          </p:nvPr>
+        </p:nvSpPr>
+        <p:spPr>
+          <a:xfrm>
+            <a:off x="11094415" y="6419088"/>
+            <a:ext cx="548640" cy="274320"/>
+          </a:xfrm>
+          <a:prstGeom prst="rect">
+            <a:avLst/>
+          </a:prstGeom>
+          <a:extLst>
+            <a:ext uri="{C572A759-6A51-4108-AA02-DFA0A04FC94B}">
+              <ma14:wrappingTextBoxFlag xmlns:ma14="http://schemas.microsoft.com/office/mac/drawingml/2011/main" val="0"/>
+            </a:ext>
+          </a:extLst>
+        </p:spPr>
+        <p:txBody>
+          <a:bodyPr/>
+          <a:lstStyle>
+            <a:lvl1pPr>
+              <a:defRPr sz="1000">
+                <a:solidFill>
+                  <a:srgbClr val="9DB8A8"/>
+                </a:solidFill>
+                <a:latin typeface="Calibri"/>
+                <a:ea typeface="Calibri"/>
+                <a:cs typeface="Calibri"/>
+              </a:defRPr>
+            </a:lvl1pPr>
+          </a:lstStyle>
+          <a:p>
+            <a:pPr algn="r"/>
+            <a:fld id="{F7021451-1387-4CA6-816F-3879F97B5CBC}" type="slidenum">
+              <a:rPr b="0" lang="en-US"/>
+              <a:t>1004</a:t>
             </a:fld>
             <a:endParaRPr lang="en-US"/>
           </a:p>
@@ -1991,6 +2173,7 @@
     <p:sldLayoutId id="2147483649" r:id="rId1"/>
     <p:sldLayoutId id="2147483650" r:id="rId2"/>
     <p:sldLayoutId id="2147483651" r:id="rId3"/>
+    <p:sldLayoutId id="2147483652" r:id="rId4"/>
   </p:sldLayoutIdLst>
   <p:hf sldNum="0" hdr="0" ftr="0" dt="0"/>
   <p:txStyles>
@@ -2273,8 +2456,8 @@
         </p:nvSpPr>
         <p:spPr>
           <a:xfrm>
-            <a:off x="914400" y="1417320"/>
-            <a:ext cx="10362895" cy="1737360"/>
+            <a:off x="548640" y="914400"/>
+            <a:ext cx="5394960" cy="2651760"/>
           </a:xfrm>
           <a:prstGeom prst="rect">
             <a:avLst/>
@@ -2286,13 +2469,13 @@
           <a:bodyPr wrap="square" rtlCol="0" anchor="b"/>
           <a:lstStyle/>
           <a:p>
-            <a:pPr algn="ctr" indent="0" marL="0">
+            <a:pPr algn="l" indent="0" marL="0">
               <a:buNone/>
             </a:pPr>
             <a:r>
               <a:rPr lang="en-US" sz="3600" b="1" dirty="0">
                 <a:solidFill>
-                  <a:schemeClr val="accent1"/>
+                  <a:schemeClr val="bg1"/>
                 </a:solidFill>
                 <a:latin typeface="Cambria" pitchFamily="34" charset="0"/>
                 <a:ea typeface="Cambria" pitchFamily="34" charset="-122"/>
@@ -2314,8 +2497,8 @@
         </p:nvSpPr>
         <p:spPr>
           <a:xfrm>
-            <a:off x="914400" y="3429000"/>
-            <a:ext cx="10362895" cy="2651760"/>
+            <a:off x="548640" y="3794760"/>
+            <a:ext cx="5120640" cy="2651760"/>
           </a:xfrm>
           <a:prstGeom prst="rect">
             <a:avLst/>
@@ -2327,13 +2510,13 @@
           <a:bodyPr wrap="square" rtlCol="0" anchor="t"/>
           <a:lstStyle/>
           <a:p>
-            <a:pPr algn="ctr" indent="0" marL="0">
+            <a:pPr algn="l" indent="0" marL="0">
               <a:buNone/>
             </a:pPr>
             <a:r>
-              <a:rPr lang="en-US" sz="1800" b="1" dirty="0">
-                <a:solidFill>
-                  <a:schemeClr val="tx1"/>
+              <a:rPr lang="en-US" sz="1600" b="1" dirty="0">
+                <a:solidFill>
+                  <a:srgbClr val="FFFFFF"/>
                 </a:solidFill>
                 <a:latin typeface="Calibri" pitchFamily="34" charset="0"/>
                 <a:ea typeface="Calibri" pitchFamily="34" charset="-122"/>
@@ -2341,16 +2524,16 @@
               </a:rPr>
               <a:t>Sanae Belfrouh · Wiame Kane · Yassine Azmou · Mohammed Yassine Sof · Hajar Elouatiq</a:t>
             </a:r>
-            <a:endParaRPr lang="en-US" sz="1800" dirty="0"/>
-          </a:p>
-          <a:p>
-            <a:pPr algn="ctr" indent="0" marL="0">
+            <a:endParaRPr lang="en-US" sz="1600" dirty="0"/>
+          </a:p>
+          <a:p>
+            <a:pPr algn="l" indent="0" marL="0">
               <a:buNone/>
             </a:pPr>
             <a:r>
-              <a:rPr lang="en-US" sz="1800" dirty="0">
-                <a:solidFill>
-                  <a:schemeClr val="tx1"/>
+              <a:rPr lang="en-US" sz="1600" dirty="0">
+                <a:solidFill>
+                  <a:srgbClr val="D8E8DC"/>
                 </a:solidFill>
                 <a:latin typeface="Calibri" pitchFamily="34" charset="0"/>
                 <a:ea typeface="Calibri" pitchFamily="34" charset="-122"/>
@@ -2358,16 +2541,16 @@
               </a:rPr>
               <a:t>Team Wiqaya — Morocco</a:t>
             </a:r>
-            <a:endParaRPr lang="en-US" sz="1800" dirty="0"/>
-          </a:p>
-          <a:p>
-            <a:pPr algn="ctr" indent="0" marL="0">
+            <a:endParaRPr lang="en-US" sz="1600" dirty="0"/>
+          </a:p>
+          <a:p>
+            <a:pPr algn="l" indent="0" marL="0">
               <a:buNone/>
             </a:pPr>
             <a:r>
               <a:rPr lang="en-US" sz="1000" dirty="0">
                 <a:solidFill>
-                  <a:schemeClr val="tx1"/>
+                  <a:srgbClr val="D8E8DC"/>
                 </a:solidFill>
                 <a:latin typeface="Calibri" pitchFamily="34" charset="0"/>
                 <a:ea typeface="Calibri" pitchFamily="34" charset="-122"/>
@@ -2375,16 +2558,16 @@
               </a:rPr>
               <a:t> </a:t>
             </a:r>
-            <a:endParaRPr lang="en-US" sz="1800" dirty="0"/>
-          </a:p>
-          <a:p>
-            <a:pPr algn="ctr" indent="0" marL="0">
+            <a:endParaRPr lang="en-US" sz="1600" dirty="0"/>
+          </a:p>
+          <a:p>
+            <a:pPr algn="l" indent="0" marL="0">
               <a:buNone/>
             </a:pPr>
             <a:r>
-              <a:rPr lang="en-US" sz="1800" dirty="0">
-                <a:solidFill>
-                  <a:schemeClr val="tx1"/>
+              <a:rPr lang="en-US" sz="1600" dirty="0">
+                <a:solidFill>
+                  <a:srgbClr val="D8E8DC"/>
                 </a:solidFill>
                 <a:latin typeface="Calibri" pitchFamily="34" charset="0"/>
                 <a:ea typeface="Calibri" pitchFamily="34" charset="-122"/>
@@ -2392,16 +2575,16 @@
               </a:rPr>
               <a:t>Arab Youth Space Hackathon 2026 · Proof of Concept</a:t>
             </a:r>
-            <a:endParaRPr lang="en-US" sz="1800" dirty="0"/>
-          </a:p>
-          <a:p>
-            <a:pPr algn="ctr" indent="0" marL="0">
+            <a:endParaRPr lang="en-US" sz="1600" dirty="0"/>
+          </a:p>
+          <a:p>
+            <a:pPr algn="l" indent="0" marL="0">
               <a:buNone/>
             </a:pPr>
             <a:r>
-              <a:rPr lang="en-US" sz="1800" i="1" dirty="0">
-                <a:solidFill>
-                  <a:schemeClr val="tx1"/>
+              <a:rPr lang="en-US" sz="1600" i="1" dirty="0">
+                <a:solidFill>
+                  <a:srgbClr val="F9C74F"/>
                 </a:solidFill>
                 <a:latin typeface="Calibri" pitchFamily="34" charset="0"/>
                 <a:ea typeface="Calibri" pitchFamily="34" charset="-122"/>
@@ -2409,16 +2592,16 @@
               </a:rPr>
               <a:t>Theme: Climate &amp; Disaster Resilience</a:t>
             </a:r>
-            <a:endParaRPr lang="en-US" sz="1800" dirty="0"/>
-          </a:p>
-          <a:p>
-            <a:pPr algn="ctr" indent="0" marL="0">
+            <a:endParaRPr lang="en-US" sz="1600" dirty="0"/>
+          </a:p>
+          <a:p>
+            <a:pPr algn="l" indent="0" marL="0">
               <a:buNone/>
             </a:pPr>
             <a:r>
               <a:rPr lang="en-US" sz="1000" dirty="0">
                 <a:solidFill>
-                  <a:schemeClr val="tx1"/>
+                  <a:srgbClr val="D8E8DC"/>
                 </a:solidFill>
                 <a:latin typeface="Calibri" pitchFamily="34" charset="0"/>
                 <a:ea typeface="Calibri" pitchFamily="34" charset="-122"/>
@@ -2426,16 +2609,16 @@
               </a:rPr>
               <a:t> </a:t>
             </a:r>
-            <a:endParaRPr lang="en-US" sz="1800" dirty="0"/>
-          </a:p>
-          <a:p>
-            <a:pPr algn="ctr" indent="0" marL="0">
+            <a:endParaRPr lang="en-US" sz="1600" dirty="0"/>
+          </a:p>
+          <a:p>
+            <a:pPr algn="l" indent="0" marL="0">
               <a:buNone/>
             </a:pPr>
             <a:r>
-              <a:rPr lang="en-US" sz="1400" dirty="0">
-                <a:solidFill>
-                  <a:schemeClr val="accent3"/>
+              <a:rPr lang="en-US" sz="1300" dirty="0">
+                <a:solidFill>
+                  <a:srgbClr val="9DB8A8"/>
                 </a:solidFill>
                 <a:latin typeface="Calibri" pitchFamily="34" charset="0"/>
                 <a:ea typeface="Calibri" pitchFamily="34" charset="-122"/>
@@ -2443,7 +2626,7 @@
               </a:rPr>
               <a:t>October 2026 · github.com/SanaeBelfrouh/wiqayagit</a:t>
             </a:r>
-            <a:endParaRPr lang="en-US" sz="1800" dirty="0"/>
+            <a:endParaRPr lang="en-US" sz="1600" dirty="0"/>
           </a:p>
         </p:txBody>
       </p:sp>
@@ -2483,7 +2666,7 @@
         <p:spPr>
           <a:xfrm>
             <a:off x="548640" y="320040"/>
-            <a:ext cx="11094415" cy="868680"/>
+            <a:ext cx="10180015" cy="868680"/>
           </a:xfrm>
           <a:prstGeom prst="rect">
             <a:avLst/>
@@ -3445,7 +3628,7 @@
         <p:spPr>
           <a:xfrm>
             <a:off x="548640" y="320040"/>
-            <a:ext cx="11094415" cy="868680"/>
+            <a:ext cx="10180015" cy="868680"/>
           </a:xfrm>
           <a:prstGeom prst="rect">
             <a:avLst/>
@@ -4223,7 +4406,7 @@
         <p:spPr>
           <a:xfrm>
             <a:off x="548640" y="320040"/>
-            <a:ext cx="11094415" cy="868680"/>
+            <a:ext cx="5669280" cy="868680"/>
           </a:xfrm>
           <a:prstGeom prst="rect">
             <a:avLst/>
@@ -4241,7 +4424,7 @@
             <a:r>
               <a:rPr lang="en-US" sz="2800" b="1" dirty="0">
                 <a:solidFill>
-                  <a:schemeClr val="accent1"/>
+                  <a:schemeClr val="bg1"/>
                 </a:solidFill>
                 <a:latin typeface="Cambria" pitchFamily="34" charset="0"/>
                 <a:ea typeface="Cambria" pitchFamily="34" charset="-122"/>
@@ -4261,8 +4444,8 @@
         </p:nvSpPr>
         <p:spPr>
           <a:xfrm>
-            <a:off x="548640" y="1371600"/>
-            <a:ext cx="6309360" cy="4480560"/>
+            <a:off x="548640" y="1280160"/>
+            <a:ext cx="5212080" cy="3383280"/>
           </a:xfrm>
           <a:prstGeom prst="rect">
             <a:avLst/>
@@ -4276,137 +4459,137 @@
           <a:p>
             <a:pPr marL="342900" indent="-342900">
               <a:spcAft>
-                <a:spcPts val="1000"/>
+                <a:spcPts val="800"/>
               </a:spcAft>
               <a:buSzPct val="100000"/>
               <a:buFont typeface="+mj-lt"/>
               <a:buAutoNum type="arabicPeriod" startAt="1"/>
             </a:pPr>
             <a:r>
-              <a:rPr lang="en-US" sz="1600" b="1" dirty="0">
-                <a:solidFill>
-                  <a:schemeClr val="tx1"/>
+              <a:rPr lang="en-US" sz="1500" b="1" dirty="0">
+                <a:solidFill>
+                  <a:srgbClr val="F9C74F"/>
                 </a:solidFill>
               </a:rPr>
               <a:t>Better predictors: </a:t>
             </a:r>
             <a:r>
-              <a:rPr lang="en-US" sz="1600" dirty="0">
-                <a:solidFill>
-                  <a:schemeClr val="tx1"/>
+              <a:rPr lang="en-US" sz="1500" dirty="0">
+                <a:solidFill>
+                  <a:schemeClr val="bg1"/>
                 </a:solidFill>
               </a:rPr>
               <a:t>land cover, OpenStreetMap distances and daily Sentinel-2 NDVI, NDMI, NBR</a:t>
             </a:r>
-            <a:endParaRPr lang="en-US" sz="1600" dirty="0"/>
+            <a:endParaRPr lang="en-US" sz="1500" dirty="0"/>
           </a:p>
           <a:p>
             <a:pPr marL="342900" indent="-342900">
               <a:spcAft>
-                <a:spcPts val="1000"/>
+                <a:spcPts val="800"/>
               </a:spcAft>
               <a:buSzPct val="100000"/>
               <a:buFont typeface="+mj-lt"/>
               <a:buAutoNum type="arabicPeriod" startAt="1"/>
             </a:pPr>
             <a:r>
-              <a:rPr lang="en-US" sz="1600" b="1" dirty="0">
-                <a:solidFill>
-                  <a:schemeClr val="tx1"/>
+              <a:rPr lang="en-US" sz="1500" b="1" dirty="0">
+                <a:solidFill>
+                  <a:srgbClr val="F9C74F"/>
                 </a:solidFill>
               </a:rPr>
               <a:t>Hyperspectral: </a:t>
             </a:r>
             <a:r>
-              <a:rPr lang="en-US" sz="1600" dirty="0">
-                <a:solidFill>
-                  <a:schemeClr val="tx1"/>
+              <a:rPr lang="en-US" sz="1500" dirty="0">
+                <a:solidFill>
+                  <a:schemeClr val="bg1"/>
                 </a:solidFill>
               </a:rPr>
               <a:t>EnMAP / Arab Satellite 813 maps of live fuel moisture and species</a:t>
             </a:r>
-            <a:endParaRPr lang="en-US" sz="1600" dirty="0"/>
+            <a:endParaRPr lang="en-US" sz="1500" dirty="0"/>
           </a:p>
           <a:p>
             <a:pPr marL="342900" indent="-342900">
               <a:spcAft>
-                <a:spcPts val="1000"/>
+                <a:spcPts val="800"/>
               </a:spcAft>
               <a:buSzPct val="100000"/>
               <a:buFont typeface="+mj-lt"/>
               <a:buAutoNum type="arabicPeriod" startAt="1"/>
             </a:pPr>
             <a:r>
-              <a:rPr lang="en-US" sz="1600" b="1" dirty="0">
-                <a:solidFill>
-                  <a:schemeClr val="tx1"/>
+              <a:rPr lang="en-US" sz="1500" b="1" dirty="0">
+                <a:solidFill>
+                  <a:srgbClr val="F9C74F"/>
                 </a:solidFill>
               </a:rPr>
               <a:t>Better reference data: </a:t>
             </a:r>
             <a:r>
-              <a:rPr lang="en-US" sz="1600" dirty="0">
-                <a:solidFill>
-                  <a:schemeClr val="tx1"/>
+              <a:rPr lang="en-US" sz="1500" dirty="0">
+                <a:solidFill>
+                  <a:schemeClr val="bg1"/>
                 </a:solidFill>
               </a:rPr>
               <a:t>validation on dNBR burned areas, not only FIRMS points</a:t>
             </a:r>
-            <a:endParaRPr lang="en-US" sz="1600" dirty="0"/>
+            <a:endParaRPr lang="en-US" sz="1500" dirty="0"/>
           </a:p>
           <a:p>
             <a:pPr marL="342900" indent="-342900">
               <a:spcAft>
-                <a:spcPts val="1000"/>
+                <a:spcPts val="800"/>
               </a:spcAft>
               <a:buSzPct val="100000"/>
               <a:buFont typeface="+mj-lt"/>
               <a:buAutoNum type="arabicPeriod" startAt="1"/>
             </a:pPr>
             <a:r>
-              <a:rPr lang="en-US" sz="1600" b="1" dirty="0">
-                <a:solidFill>
-                  <a:schemeClr val="tx1"/>
+              <a:rPr lang="en-US" sz="1500" b="1" dirty="0">
+                <a:solidFill>
+                  <a:srgbClr val="F9C74F"/>
                 </a:solidFill>
               </a:rPr>
               <a:t>Operations: </a:t>
             </a:r>
             <a:r>
-              <a:rPr lang="en-US" sz="1600" dirty="0">
-                <a:solidFill>
-                  <a:schemeClr val="tx1"/>
+              <a:rPr lang="en-US" sz="1500" dirty="0">
+                <a:solidFill>
+                  <a:schemeClr val="bg1"/>
                 </a:solidFill>
               </a:rPr>
               <a:t>SMS gateway, daily batch processing, alert workflow with forest managers</a:t>
             </a:r>
-            <a:endParaRPr lang="en-US" sz="1600" dirty="0"/>
+            <a:endParaRPr lang="en-US" sz="1500" dirty="0"/>
           </a:p>
           <a:p>
             <a:pPr marL="342900" indent="-342900">
               <a:spcAft>
-                <a:spcPts val="1000"/>
+                <a:spcPts val="800"/>
               </a:spcAft>
               <a:buSzPct val="100000"/>
               <a:buFont typeface="+mj-lt"/>
               <a:buAutoNum type="arabicPeriod" startAt="1"/>
             </a:pPr>
             <a:r>
-              <a:rPr lang="en-US" sz="1600" b="1" dirty="0">
-                <a:solidFill>
-                  <a:schemeClr val="tx1"/>
+              <a:rPr lang="en-US" sz="1500" b="1" dirty="0">
+                <a:solidFill>
+                  <a:srgbClr val="F9C74F"/>
                 </a:solidFill>
               </a:rPr>
               <a:t>Pilot: </a:t>
             </a:r>
             <a:r>
-              <a:rPr lang="en-US" sz="1600" dirty="0">
-                <a:solidFill>
-                  <a:schemeClr val="tx1"/>
+              <a:rPr lang="en-US" sz="1500" dirty="0">
+                <a:solidFill>
+                  <a:schemeClr val="bg1"/>
                 </a:solidFill>
               </a:rPr>
               <a:t>one fire season in Bouhachem, Derdara and Jbel Sougna, then other Mediterranean forests</a:t>
             </a:r>
-            <a:endParaRPr lang="en-US" sz="1600" dirty="0"/>
+            <a:endParaRPr lang="en-US" sz="1500" dirty="0"/>
           </a:p>
         </p:txBody>
       </p:sp>
@@ -4418,18 +4601,22 @@
         </p:nvSpPr>
         <p:spPr>
           <a:xfrm>
-            <a:off x="6949440" y="1463040"/>
-            <a:ext cx="4690872" cy="2651760"/>
+            <a:off x="548640" y="4800600"/>
+            <a:ext cx="5029200" cy="1417320"/>
           </a:xfrm>
-          <a:prstGeom prst="rect">
-            <a:avLst/>
+          <a:prstGeom prst="roundRect">
+            <a:avLst>
+              <a:gd name="adj" fmla="val 5161"/>
+            </a:avLst>
           </a:prstGeom>
           <a:solidFill>
-            <a:schemeClr val="bg2"/>
+            <a:srgbClr val="0E2A20">
+              <a:alpha val="85000"/>
+            </a:srgbClr>
           </a:solidFill>
-          <a:ln w="9525">
+          <a:ln w="12700">
             <a:solidFill>
-              <a:srgbClr val="C8D1CB"/>
+              <a:schemeClr val="accent4"/>
             </a:solidFill>
             <a:prstDash val="solid"/>
           </a:ln>
@@ -4443,8 +4630,8 @@
         </p:nvSpPr>
         <p:spPr>
           <a:xfrm>
-            <a:off x="7086600" y="1600200"/>
-            <a:ext cx="4480560" cy="2377440"/>
+            <a:off x="713232" y="4892040"/>
+            <a:ext cx="4754880" cy="1261872"/>
           </a:xfrm>
           <a:prstGeom prst="rect">
             <a:avLst/>
@@ -4458,48 +4645,48 @@
           <a:p>
             <a:pPr indent="0" marL="0">
               <a:spcAft>
-                <a:spcPts val="600"/>
+                <a:spcPts val="300"/>
               </a:spcAft>
               <a:buNone/>
             </a:pPr>
             <a:r>
-              <a:rPr lang="en-US" sz="1600" b="1" dirty="0">
-                <a:solidFill>
-                  <a:schemeClr val="accent1"/>
+              <a:rPr lang="en-US" sz="1400" b="1" dirty="0">
+                <a:solidFill>
+                  <a:schemeClr val="accent6"/>
                 </a:solidFill>
               </a:rPr>
               <a:t>Reproduce the headline result</a:t>
             </a:r>
-            <a:endParaRPr lang="en-US" sz="1500" dirty="0"/>
+            <a:endParaRPr lang="en-US" sz="1400" dirty="0"/>
           </a:p>
           <a:p>
             <a:pPr indent="0" marL="0">
               <a:spcAft>
-                <a:spcPts val="600"/>
+                <a:spcPts val="300"/>
               </a:spcAft>
               <a:buNone/>
             </a:pPr>
             <a:r>
-              <a:rPr lang="en-US" sz="1500" dirty="0">
-                <a:solidFill>
-                  <a:schemeClr val="tx1"/>
+              <a:rPr lang="en-US" sz="1300" dirty="0">
+                <a:solidFill>
+                  <a:schemeClr val="bg1"/>
                 </a:solidFill>
               </a:rPr>
               <a:t>github.com/SanaeBelfrouh/wiqayagit</a:t>
             </a:r>
-            <a:endParaRPr lang="en-US" sz="1500" dirty="0"/>
+            <a:endParaRPr lang="en-US" sz="1400" dirty="0"/>
           </a:p>
           <a:p>
             <a:pPr indent="0" marL="0">
               <a:spcAft>
-                <a:spcPts val="600"/>
+                <a:spcPts val="300"/>
               </a:spcAft>
               <a:buNone/>
             </a:pPr>
             <a:r>
-              <a:rPr lang="en-US" sz="1200" dirty="0">
-                <a:solidFill>
-                  <a:schemeClr val="tx1"/>
+              <a:rPr lang="en-US" sz="1100" dirty="0">
+                <a:solidFill>
+                  <a:schemeClr val="bg1"/>
                 </a:solidFill>
                 <a:latin typeface="Courier New" pitchFamily="34" charset="0"/>
                 <a:ea typeface="Courier New" pitchFamily="34" charset="-122"/>
@@ -4507,19 +4694,19 @@
               </a:rPr>
               <a:t>pip install -r requirements.txt</a:t>
             </a:r>
-            <a:endParaRPr lang="en-US" sz="1500" dirty="0"/>
+            <a:endParaRPr lang="en-US" sz="1400" dirty="0"/>
           </a:p>
           <a:p>
             <a:pPr indent="0" marL="0">
               <a:spcAft>
-                <a:spcPts val="600"/>
+                <a:spcPts val="300"/>
               </a:spcAft>
               <a:buNone/>
             </a:pPr>
             <a:r>
-              <a:rPr lang="en-US" sz="1200" dirty="0">
-                <a:solidFill>
-                  <a:schemeClr val="tx1"/>
+              <a:rPr lang="en-US" sz="1100" dirty="0">
+                <a:solidFill>
+                  <a:schemeClr val="bg1"/>
                 </a:solidFill>
                 <a:latin typeface="Courier New" pitchFamily="34" charset="0"/>
                 <a:ea typeface="Courier New" pitchFamily="34" charset="-122"/>
@@ -4527,24 +4714,7 @@
               </a:rPr>
               <a:t>jupyter lab notebooks/02_main_analysis.ipynb</a:t>
             </a:r>
-            <a:endParaRPr lang="en-US" sz="1500" dirty="0"/>
-          </a:p>
-          <a:p>
-            <a:pPr indent="0" marL="0">
-              <a:spcAft>
-                <a:spcPts val="600"/>
-              </a:spcAft>
-              <a:buNone/>
-            </a:pPr>
-            <a:r>
-              <a:rPr lang="en-US" sz="1400" i="1" dirty="0">
-                <a:solidFill>
-                  <a:schemeClr val="tx1"/>
-                </a:solidFill>
-              </a:rPr>
-              <a:t>About 5 minutes on a standard laptop</a:t>
-            </a:r>
-            <a:endParaRPr lang="en-US" sz="1500" dirty="0"/>
+            <a:endParaRPr lang="en-US" sz="1400" dirty="0"/>
           </a:p>
         </p:txBody>
       </p:sp>
@@ -4578,7 +4748,7 @@
             <a:lvl1pPr>
               <a:defRPr sz="1000">
                 <a:solidFill>
-                  <a:schemeClr val="accent3"/>
+                  <a:srgbClr val="9DB8A8"/>
                 </a:solidFill>
                 <a:latin typeface="Calibri"/>
                 <a:ea typeface="Calibri"/>
@@ -4632,7 +4802,7 @@
         <p:spPr>
           <a:xfrm>
             <a:off x="548640" y="320040"/>
-            <a:ext cx="11094415" cy="868680"/>
+            <a:ext cx="10180015" cy="868680"/>
           </a:xfrm>
           <a:prstGeom prst="rect">
             <a:avLst/>
@@ -4904,7 +5074,7 @@
         <p:spPr>
           <a:xfrm>
             <a:off x="548640" y="320040"/>
-            <a:ext cx="11094415" cy="868680"/>
+            <a:ext cx="10180015" cy="868680"/>
           </a:xfrm>
           <a:prstGeom prst="rect">
             <a:avLst/>
@@ -5060,16 +5230,40 @@
           </a:p>
         </p:txBody>
       </p:sp>
-      <p:sp>
-        <p:nvSpPr>
-          <p:cNvPr id="4" name="Text 2"/>
+      <p:pic>
+        <p:nvPicPr>
+          <p:cNvPr id="4" name="Flame icon 1" descr="Flame icon 1">    </p:cNvPr>
+          <p:cNvPicPr>
+            <a:picLocks noChangeAspect="1"/>
+          </p:cNvPicPr>
+          <p:nvPr/>
+        </p:nvPicPr>
+        <p:blipFill>
+          <a:blip r:embed="rId1"/>
+          <a:stretch>
+            <a:fillRect/>
+          </a:stretch>
+        </p:blipFill>
+        <p:spPr>
+          <a:xfrm>
+            <a:off x="548640" y="4956048"/>
+            <a:ext cx="384048" cy="384048"/>
+          </a:xfrm>
+          <a:prstGeom prst="rect">
+            <a:avLst/>
+          </a:prstGeom>
+        </p:spPr>
+      </p:pic>
+      <p:sp>
+        <p:nvSpPr>
+          <p:cNvPr id="5" name="Text 2"/>
           <p:cNvSpPr txBox="1"/>
           <p:nvPr/>
         </p:nvSpPr>
         <p:spPr>
           <a:xfrm>
-            <a:off x="548640" y="4892040"/>
-            <a:ext cx="2011680" cy="548640"/>
+            <a:off x="987552" y="4892040"/>
+            <a:ext cx="1645920" cy="548640"/>
           </a:xfrm>
           <a:prstGeom prst="rect">
             <a:avLst/>
@@ -5085,7 +5279,7 @@
               <a:buNone/>
             </a:pPr>
             <a:r>
-              <a:rPr lang="en-US" sz="3000" b="1" dirty="0">
+              <a:rPr lang="en-US" sz="2800" b="1" dirty="0">
                 <a:solidFill>
                   <a:schemeClr val="accent2"/>
                 </a:solidFill>
@@ -5095,13 +5289,13 @@
               </a:rPr>
               <a:t>10,600</a:t>
             </a:r>
-            <a:endParaRPr lang="en-US" sz="3000" dirty="0"/>
+            <a:endParaRPr lang="en-US" sz="2800" dirty="0"/>
           </a:p>
         </p:txBody>
       </p:sp>
       <p:sp>
         <p:nvSpPr>
-          <p:cNvPr id="5" name="Text 3"/>
+          <p:cNvPr id="6" name="Text 3"/>
           <p:cNvSpPr txBox="1"/>
           <p:nvPr/>
         </p:nvSpPr>
@@ -5135,16 +5329,40 @@
           </a:p>
         </p:txBody>
       </p:sp>
-      <p:sp>
-        <p:nvSpPr>
-          <p:cNvPr id="6" name="Text 4"/>
+      <p:pic>
+        <p:nvPicPr>
+          <p:cNvPr id="7" name="Flame icon 2" descr="Flame icon 2">    </p:cNvPr>
+          <p:cNvPicPr>
+            <a:picLocks noChangeAspect="1"/>
+          </p:cNvPicPr>
+          <p:nvPr/>
+        </p:nvPicPr>
+        <p:blipFill>
+          <a:blip r:embed="rId2"/>
+          <a:stretch>
+            <a:fillRect/>
+          </a:stretch>
+        </p:blipFill>
+        <p:spPr>
+          <a:xfrm>
+            <a:off x="2697480" y="4956048"/>
+            <a:ext cx="384048" cy="384048"/>
+          </a:xfrm>
+          <a:prstGeom prst="rect">
+            <a:avLst/>
+          </a:prstGeom>
+        </p:spPr>
+      </p:pic>
+      <p:sp>
+        <p:nvSpPr>
+          <p:cNvPr id="8" name="Text 4"/>
           <p:cNvSpPr txBox="1"/>
           <p:nvPr/>
         </p:nvSpPr>
         <p:spPr>
           <a:xfrm>
-            <a:off x="2697480" y="4892040"/>
-            <a:ext cx="2011680" cy="548640"/>
+            <a:off x="3136392" y="4892040"/>
+            <a:ext cx="1645920" cy="548640"/>
           </a:xfrm>
           <a:prstGeom prst="rect">
             <a:avLst/>
@@ -5160,7 +5378,7 @@
               <a:buNone/>
             </a:pPr>
             <a:r>
-              <a:rPr lang="en-US" sz="3000" b="1" dirty="0">
+              <a:rPr lang="en-US" sz="2800" b="1" dirty="0">
                 <a:solidFill>
                   <a:schemeClr val="accent2"/>
                 </a:solidFill>
@@ -5170,13 +5388,13 @@
               </a:rPr>
               <a:t>264,000</a:t>
             </a:r>
-            <a:endParaRPr lang="en-US" sz="3000" dirty="0"/>
+            <a:endParaRPr lang="en-US" sz="2800" dirty="0"/>
           </a:p>
         </p:txBody>
       </p:sp>
       <p:sp>
         <p:nvSpPr>
-          <p:cNvPr id="7" name="Text 5"/>
+          <p:cNvPr id="9" name="Text 5"/>
           <p:cNvSpPr txBox="1"/>
           <p:nvPr/>
         </p:nvSpPr>
@@ -5210,16 +5428,40 @@
           </a:p>
         </p:txBody>
       </p:sp>
-      <p:sp>
-        <p:nvSpPr>
-          <p:cNvPr id="8" name="Text 6"/>
+      <p:pic>
+        <p:nvPicPr>
+          <p:cNvPr id="10" name="Flame icon 3" descr="Flame icon 3">    </p:cNvPr>
+          <p:cNvPicPr>
+            <a:picLocks noChangeAspect="1"/>
+          </p:cNvPicPr>
+          <p:nvPr/>
+        </p:nvPicPr>
+        <p:blipFill>
+          <a:blip r:embed="rId3"/>
+          <a:stretch>
+            <a:fillRect/>
+          </a:stretch>
+        </p:blipFill>
+        <p:spPr>
+          <a:xfrm>
+            <a:off x="4846320" y="4956048"/>
+            <a:ext cx="384048" cy="384048"/>
+          </a:xfrm>
+          <a:prstGeom prst="rect">
+            <a:avLst/>
+          </a:prstGeom>
+        </p:spPr>
+      </p:pic>
+      <p:sp>
+        <p:nvSpPr>
+          <p:cNvPr id="11" name="Text 6"/>
           <p:cNvSpPr txBox="1"/>
           <p:nvPr/>
         </p:nvSpPr>
         <p:spPr>
           <a:xfrm>
-            <a:off x="4846320" y="4892040"/>
-            <a:ext cx="2011680" cy="548640"/>
+            <a:off x="5285232" y="4892040"/>
+            <a:ext cx="1645920" cy="548640"/>
           </a:xfrm>
           <a:prstGeom prst="rect">
             <a:avLst/>
@@ -5235,7 +5477,7 @@
               <a:buNone/>
             </a:pPr>
             <a:r>
-              <a:rPr lang="en-US" sz="3000" b="1" dirty="0">
+              <a:rPr lang="en-US" sz="2800" b="1" dirty="0">
                 <a:solidFill>
                   <a:schemeClr val="accent2"/>
                 </a:solidFill>
@@ -5245,13 +5487,13 @@
               </a:rPr>
               <a:t>445</a:t>
             </a:r>
-            <a:endParaRPr lang="en-US" sz="3000" dirty="0"/>
+            <a:endParaRPr lang="en-US" sz="2800" dirty="0"/>
           </a:p>
         </p:txBody>
       </p:sp>
       <p:sp>
         <p:nvSpPr>
-          <p:cNvPr id="9" name="Text 7"/>
+          <p:cNvPr id="12" name="Text 7"/>
           <p:cNvSpPr txBox="1"/>
           <p:nvPr/>
         </p:nvSpPr>
@@ -5287,14 +5529,14 @@
       </p:sp>
       <p:pic>
         <p:nvPicPr>
-          <p:cNvPr id="10" name="Study area map" descr="/home/user/wiqayagit/results/study_area_firms.png">    </p:cNvPr>
+          <p:cNvPr id="13" name="Study area map" descr="Study area map">    </p:cNvPr>
           <p:cNvPicPr>
             <a:picLocks noChangeAspect="1"/>
           </p:cNvPicPr>
           <p:nvPr/>
         </p:nvPicPr>
         <p:blipFill>
-          <a:blip r:embed="rId1"/>
+          <a:blip r:embed="rId4"/>
           <a:stretch>
             <a:fillRect/>
           </a:stretch>
@@ -5311,7 +5553,7 @@
       </p:pic>
       <p:sp>
         <p:nvSpPr>
-          <p:cNvPr id="11" name="Text 8"/>
+          <p:cNvPr id="14" name="Text 8"/>
           <p:cNvSpPr txBox="1"/>
           <p:nvPr/>
         </p:nvSpPr>
@@ -5429,7 +5671,7 @@
         <p:spPr>
           <a:xfrm>
             <a:off x="548640" y="320040"/>
-            <a:ext cx="11094415" cy="868680"/>
+            <a:ext cx="10180015" cy="868680"/>
           </a:xfrm>
           <a:prstGeom prst="rect">
             <a:avLst/>
@@ -6248,7 +6490,7 @@
         <p:spPr>
           <a:xfrm>
             <a:off x="548640" y="320040"/>
-            <a:ext cx="11094415" cy="868680"/>
+            <a:ext cx="10180015" cy="868680"/>
           </a:xfrm>
           <a:prstGeom prst="rect">
             <a:avLst/>
@@ -8292,7 +8534,7 @@
         <p:spPr>
           <a:xfrm>
             <a:off x="548640" y="320040"/>
-            <a:ext cx="11094415" cy="868680"/>
+            <a:ext cx="10180015" cy="868680"/>
           </a:xfrm>
           <a:prstGeom prst="rect">
             <a:avLst/>
@@ -8333,13 +8575,15 @@
             <a:off x="548640" y="1417320"/>
             <a:ext cx="2377440" cy="1600200"/>
           </a:xfrm>
-          <a:prstGeom prst="rect">
-            <a:avLst/>
+          <a:prstGeom prst="roundRect">
+            <a:avLst>
+              <a:gd name="adj" fmla="val 4571"/>
+            </a:avLst>
           </a:prstGeom>
           <a:solidFill>
-            <a:schemeClr val="bg2"/>
+            <a:schemeClr val="bg1"/>
           </a:solidFill>
-          <a:ln w="12700">
+          <a:ln w="15875">
             <a:solidFill>
               <a:schemeClr val="accent1"/>
             </a:solidFill>
@@ -8432,13 +8676,15 @@
             <a:off x="3454298" y="1417320"/>
             <a:ext cx="2377440" cy="1600200"/>
           </a:xfrm>
-          <a:prstGeom prst="rect">
-            <a:avLst/>
+          <a:prstGeom prst="roundRect">
+            <a:avLst>
+              <a:gd name="adj" fmla="val 4571"/>
+            </a:avLst>
           </a:prstGeom>
           <a:solidFill>
-            <a:schemeClr val="bg2"/>
+            <a:schemeClr val="bg1"/>
           </a:solidFill>
-          <a:ln w="12700">
+          <a:ln w="15875">
             <a:solidFill>
               <a:schemeClr val="accent1"/>
             </a:solidFill>
@@ -8531,15 +8777,17 @@
             <a:off x="6359957" y="1417320"/>
             <a:ext cx="2377440" cy="1600200"/>
           </a:xfrm>
-          <a:prstGeom prst="rect">
-            <a:avLst/>
+          <a:prstGeom prst="roundRect">
+            <a:avLst>
+              <a:gd name="adj" fmla="val 4571"/>
+            </a:avLst>
           </a:prstGeom>
           <a:solidFill>
-            <a:schemeClr val="bg2"/>
+            <a:schemeClr val="bg1"/>
           </a:solidFill>
-          <a:ln w="12700">
+          <a:ln w="15875">
             <a:solidFill>
-              <a:schemeClr val="accent1"/>
+              <a:schemeClr val="accent2"/>
             </a:solidFill>
             <a:prstDash val="solid"/>
           </a:ln>
@@ -8572,7 +8820,7 @@
             <a:r>
               <a:rPr lang="en-US" sz="1500" b="1" dirty="0">
                 <a:solidFill>
-                  <a:schemeClr val="accent1"/>
+                  <a:schemeClr val="accent2"/>
                 </a:solidFill>
               </a:rPr>
               <a:t>3. Fire history</a:t>
@@ -8630,13 +8878,15 @@
             <a:off x="9265615" y="1417320"/>
             <a:ext cx="2377440" cy="1600200"/>
           </a:xfrm>
-          <a:prstGeom prst="rect">
-            <a:avLst/>
+          <a:prstGeom prst="roundRect">
+            <a:avLst>
+              <a:gd name="adj" fmla="val 4571"/>
+            </a:avLst>
           </a:prstGeom>
           <a:solidFill>
-            <a:schemeClr val="bg2"/>
+            <a:schemeClr val="bg1"/>
           </a:solidFill>
-          <a:ln w="12700">
+          <a:ln w="15875">
             <a:solidFill>
               <a:schemeClr val="accent1"/>
             </a:solidFill>
@@ -8705,13 +8955,15 @@
             <a:off x="548640" y="3703320"/>
             <a:ext cx="2377440" cy="1600200"/>
           </a:xfrm>
-          <a:prstGeom prst="rect">
-            <a:avLst/>
+          <a:prstGeom prst="roundRect">
+            <a:avLst>
+              <a:gd name="adj" fmla="val 4571"/>
+            </a:avLst>
           </a:prstGeom>
           <a:solidFill>
-            <a:schemeClr val="bg2"/>
+            <a:schemeClr val="bg1"/>
           </a:solidFill>
-          <a:ln w="12700">
+          <a:ln w="15875">
             <a:solidFill>
               <a:schemeClr val="accent1"/>
             </a:solidFill>
@@ -8804,13 +9056,15 @@
             <a:off x="3454298" y="3703320"/>
             <a:ext cx="2377440" cy="1600200"/>
           </a:xfrm>
-          <a:prstGeom prst="rect">
-            <a:avLst/>
+          <a:prstGeom prst="roundRect">
+            <a:avLst>
+              <a:gd name="adj" fmla="val 4571"/>
+            </a:avLst>
           </a:prstGeom>
           <a:solidFill>
-            <a:schemeClr val="bg2"/>
+            <a:schemeClr val="bg1"/>
           </a:solidFill>
-          <a:ln w="12700">
+          <a:ln w="15875">
             <a:solidFill>
               <a:schemeClr val="accent1"/>
             </a:solidFill>
@@ -8903,13 +9157,15 @@
             <a:off x="6359957" y="3703320"/>
             <a:ext cx="2377440" cy="1600200"/>
           </a:xfrm>
-          <a:prstGeom prst="rect">
-            <a:avLst/>
+          <a:prstGeom prst="roundRect">
+            <a:avLst>
+              <a:gd name="adj" fmla="val 4571"/>
+            </a:avLst>
           </a:prstGeom>
           <a:solidFill>
-            <a:schemeClr val="bg2"/>
+            <a:schemeClr val="bg1"/>
           </a:solidFill>
-          <a:ln w="12700">
+          <a:ln w="15875">
             <a:solidFill>
               <a:schemeClr val="accent1"/>
             </a:solidFill>
@@ -9002,15 +9258,17 @@
             <a:off x="9265615" y="3703320"/>
             <a:ext cx="2377440" cy="1600200"/>
           </a:xfrm>
-          <a:prstGeom prst="rect">
-            <a:avLst/>
+          <a:prstGeom prst="roundRect">
+            <a:avLst>
+              <a:gd name="adj" fmla="val 4571"/>
+            </a:avLst>
           </a:prstGeom>
           <a:solidFill>
-            <a:schemeClr val="bg2"/>
+            <a:schemeClr val="bg1"/>
           </a:solidFill>
-          <a:ln w="12700">
+          <a:ln w="15875">
             <a:solidFill>
-              <a:schemeClr val="accent1"/>
+              <a:schemeClr val="accent2"/>
             </a:solidFill>
             <a:prstDash val="solid"/>
           </a:ln>
@@ -9043,7 +9301,7 @@
             <a:r>
               <a:rPr lang="en-US" sz="1500" b="1" dirty="0">
                 <a:solidFill>
-                  <a:schemeClr val="accent1"/>
+                  <a:schemeClr val="accent2"/>
                 </a:solidFill>
               </a:rPr>
               <a:t>8. Weather danger</a:t>
@@ -9256,7 +9514,7 @@
         <p:spPr>
           <a:xfrm>
             <a:off x="548640" y="320040"/>
-            <a:ext cx="11094415" cy="868680"/>
+            <a:ext cx="10180015" cy="868680"/>
           </a:xfrm>
           <a:prstGeom prst="rect">
             <a:avLst/>
@@ -9288,7 +9546,7 @@
       </p:sp>
       <p:pic>
         <p:nvPicPr>
-          <p:cNvPr id="3" name="Headline result map" descr="/home/user/wiqayagit/results/example_output.png">    </p:cNvPr>
+          <p:cNvPr id="3" name="Headline result map" descr="Headline result map">    </p:cNvPr>
           <p:cNvPicPr>
             <a:picLocks noChangeAspect="1"/>
           </p:cNvPicPr>
@@ -9429,7 +9687,7 @@
         <p:spPr>
           <a:xfrm>
             <a:off x="548640" y="320040"/>
-            <a:ext cx="11094415" cy="868680"/>
+            <a:ext cx="10180015" cy="868680"/>
           </a:xfrm>
           <a:prstGeom prst="rect">
             <a:avLst/>
@@ -9461,7 +9719,7 @@
       </p:sp>
       <p:pic>
         <p:nvPicPr>
-          <p:cNvPr id="3" name="Feature importance chart" descr="/home/user/wiqayagit/results/feature_importance.png">    </p:cNvPr>
+          <p:cNvPr id="3" name="Feature importance chart" descr="Feature importance chart">    </p:cNvPr>
           <p:cNvPicPr>
             <a:picLocks noChangeAspect="1"/>
           </p:cNvPicPr>
@@ -9729,7 +9987,7 @@
         <p:spPr>
           <a:xfrm>
             <a:off x="548640" y="320040"/>
-            <a:ext cx="11094415" cy="868680"/>
+            <a:ext cx="10180015" cy="868680"/>
           </a:xfrm>
           <a:prstGeom prst="rect">
             <a:avLst/>
@@ -9761,7 +10019,7 @@
       </p:sp>
       <p:pic>
         <p:nvPicPr>
-          <p:cNvPr id="3" name="Risk map screenshot" descr="/home/user/wiqayagit/docs/screenshots/risk-map-en.png">    </p:cNvPr>
+          <p:cNvPr id="3" name="Risk map screenshot" descr="Risk map screenshot">    </p:cNvPr>
           <p:cNvPicPr>
             <a:picLocks noChangeAspect="1"/>
           </p:cNvPicPr>
@@ -9785,7 +10043,7 @@
       </p:pic>
       <p:pic>
         <p:nvPicPr>
-          <p:cNvPr id="4" name="Fire history screenshot" descr="/home/user/wiqayagit/docs/screenshots/fire-history-en.png">    </p:cNvPr>
+          <p:cNvPr id="4" name="Fire history screenshot" descr="Fire history screenshot">    </p:cNvPr>
           <p:cNvPicPr>
             <a:picLocks noChangeAspect="1"/>
           </p:cNvPicPr>
@@ -9963,7 +10221,7 @@
         <p:spPr>
           <a:xfrm>
             <a:off x="548640" y="320040"/>
-            <a:ext cx="11094415" cy="868680"/>
+            <a:ext cx="10180015" cy="868680"/>
           </a:xfrm>
           <a:prstGeom prst="rect">
             <a:avLst/>
@@ -9995,7 +10253,7 @@
       </p:sp>
       <p:pic>
         <p:nvPicPr>
-          <p:cNvPr id="3" name="Arabic interface screenshot" descr="/home/user/wiqayagit/docs/screenshots/home-ar.png">    </p:cNvPr>
+          <p:cNvPr id="3" name="Arabic interface screenshot" descr="Arabic interface screenshot">    </p:cNvPr>
           <p:cNvPicPr>
             <a:picLocks noChangeAspect="1"/>
           </p:cNvPicPr>
@@ -10055,7 +10313,7 @@
       </p:sp>
       <p:pic>
         <p:nvPicPr>
-          <p:cNvPr id="5" name="Phone fire history" descr="/home/user/wiqayagit/docs/screenshots/phone-fire-history-en.png">    </p:cNvPr>
+          <p:cNvPr id="5" name="Phone fire history" descr="Phone fire history">    </p:cNvPr>
           <p:cNvPicPr>
             <a:picLocks noChangeAspect="1"/>
           </p:cNvPicPr>
@@ -10079,7 +10337,7 @@
       </p:pic>
       <p:pic>
         <p:nvPicPr>
-          <p:cNvPr id="6" name="Phone alert form" descr="/home/user/wiqayagit/docs/screenshots/phone-alerts-en.png">    </p:cNvPr>
+          <p:cNvPr id="6" name="Phone alert form" descr="Phone alert form">    </p:cNvPr>
           <p:cNvPicPr>
             <a:picLocks noChangeAspect="1"/>
           </p:cNvPicPr>
@@ -10194,47 +10452,47 @@
 </file>
 
 <file path=ppt/theme/theme1.xml><?xml version="1.0" encoding="utf-8"?>
-<a:theme xmlns:a="http://schemas.openxmlformats.org/drawingml/2006/main" name="Wiqaya Academic">
+<a:theme xmlns:a="http://schemas.openxmlformats.org/drawingml/2006/main" name="Wiqaya Forest and Space">
   <a:themeElements>
-    <a:clrScheme name="Wiqaya Academic">
+    <a:clrScheme name="Wiqaya Forest and Space">
       <a:dk1>
-        <a:srgbClr val="222222"/>
+        <a:srgbClr val="1F2A24"/>
       </a:dk1>
       <a:lt1>
         <a:srgbClr val="FFFFFF"/>
       </a:lt1>
       <a:dk2>
-        <a:srgbClr val="1E4D3A"/>
+        <a:srgbClr val="0E2A20"/>
       </a:dk2>
       <a:lt2>
-        <a:srgbClr val="EEF2EF"/>
+        <a:srgbClr val="F4F7F2"/>
       </a:lt2>
       <a:accent1>
-        <a:srgbClr val="1E4D3A"/>
+        <a:srgbClr val="1B4332"/>
       </a:accent1>
       <a:accent2>
-        <a:srgbClr val="A33A2B"/>
+        <a:srgbClr val="E8590C"/>
       </a:accent2>
       <a:accent3>
         <a:srgbClr val="5F6F66"/>
       </a:accent3>
       <a:accent4>
-        <a:srgbClr val="C9A227"/>
+        <a:srgbClr val="2A9D8F"/>
       </a:accent4>
       <a:accent5>
-        <a:srgbClr val="4A6FA5"/>
+        <a:srgbClr val="F9C74F"/>
       </a:accent5>
       <a:accent6>
-        <a:srgbClr val="8C8C8C"/>
+        <a:srgbClr val="8ECAE6"/>
       </a:accent6>
       <a:hlink>
-        <a:srgbClr val="1F5FA8"/>
+        <a:srgbClr val="2A9D8F"/>
       </a:hlink>
       <a:folHlink>
         <a:srgbClr val="6B4FA0"/>
       </a:folHlink>
     </a:clrScheme>
-    <a:fontScheme name="Wiqaya Academic">
+    <a:fontScheme name="Wiqaya Forest and Space">
       <a:majorFont>
         <a:latin typeface="Cambria"/>
         <a:ea typeface=""/>

</xml_diff>

<commit_message>
Cite the DEM source: FABDEM V1-2 (University of Bristol)
README data table and attribution, data/README.md and slides (data
table and references) now cite FABDEM V1-2, the Copernicus GLO-30 DEM
with forests and buildings removed, CC BY-NC-SA 4.0.
</commit_message>
<xml_diff>
--- a/docs/slides.pptx
+++ b/docs/slides.pptx
@@ -4882,6 +4882,23 @@
                   <a:schemeClr val="tx1"/>
                 </a:solidFill>
               </a:rPr>
+              <a:t>Hawker, L. et al. (2022). A 30 m global map of elevation with forests and buildings removed (FABDEM). Environ. Res. Lett., 17, 024016.</a:t>
+            </a:r>
+            <a:endParaRPr lang="en-US" sz="1400" dirty="0"/>
+          </a:p>
+          <a:p>
+            <a:pPr indent="0" marL="0">
+              <a:spcAft>
+                <a:spcPts val="900"/>
+              </a:spcAft>
+              <a:buNone/>
+            </a:pPr>
+            <a:r>
+              <a:rPr lang="en-US" sz="1400" dirty="0">
+                <a:solidFill>
+                  <a:schemeClr val="tx1"/>
+                </a:solidFill>
+              </a:rPr>
               <a:t>Hersbach, H. et al. (2020). The ERA5 global reanalysis. Q. J. R. Meteorol. Soc., 146, 1999–2049.</a:t>
             </a:r>
             <a:endParaRPr lang="en-US" sz="1400" dirty="0"/>
@@ -7167,7 +7184,7 @@
                           <a:ea typeface="Calibri" pitchFamily="34" charset="-122"/>
                           <a:cs typeface="Calibri" pitchFamily="34" charset="-120"/>
                         </a:rPr>
-                        <a:t>Digital elevation model, ≈30 m</a:t>
+                        <a:t>FABDEM V1-2, 30 m (Univ. of Bristol; Copernicus GLO-30)</a:t>
                       </a:r>
                       <a:endParaRPr lang="en-US" sz="1400" dirty="0">
                         <a:latin typeface="Calibri" charset="0"/>
@@ -7232,7 +7249,7 @@
                           <a:ea typeface="Calibri" pitchFamily="34" charset="-122"/>
                           <a:cs typeface="Calibri" pitchFamily="34" charset="-120"/>
                         </a:rPr>
-                        <a:t>static</a:t>
+                        <a:t>2023 release</a:t>
                       </a:r>
                       <a:endParaRPr lang="en-US" sz="1400" dirty="0">
                         <a:latin typeface="Calibri" charset="0"/>

</xml_diff>